<commit_message>
reporte: actualizar cierre_base_dev.pptx (bajo demanda, modulo dev)
</commit_message>
<xml_diff>
--- a/cierre_base_dev.pptx
+++ b/cierre_base_dev.pptx
@@ -8977,7 +8977,7 @@
                 </a:solidFill>
                 <a:latin typeface="Calibri"/>
               </a:rPr>
-              <a:t>92%</a:t>
+              <a:t>93%</a:t>
             </a:r>
           </a:p>
         </p:txBody>
@@ -9831,7 +9831,7 @@
                 </a:solidFill>
                 <a:latin typeface="Calibri"/>
               </a:rPr>
-              <a:t>91%</a:t>
+              <a:t>92%</a:t>
             </a:r>
           </a:p>
         </p:txBody>
@@ -10258,7 +10258,7 @@
                 </a:solidFill>
                 <a:latin typeface="Calibri"/>
               </a:rPr>
-              <a:t>91%</a:t>
+              <a:t>92%</a:t>
             </a:r>
           </a:p>
         </p:txBody>
@@ -10685,7 +10685,7 @@
                 </a:solidFill>
                 <a:latin typeface="Calibri"/>
               </a:rPr>
-              <a:t>91%</a:t>
+              <a:t>92%</a:t>
             </a:r>
           </a:p>
         </p:txBody>
@@ -11112,7 +11112,7 @@
                 </a:solidFill>
                 <a:latin typeface="Calibri"/>
               </a:rPr>
-              <a:t>91%</a:t>
+              <a:t>92%</a:t>
             </a:r>
           </a:p>
         </p:txBody>

</xml_diff>